<commit_message>
feat: publish AI-first infographic courseware v12
</commit_message>
<xml_diff>
--- a/activities/Activity-01-Decode-a-Customer-Survey-Infographic/A01-Decode-a-Customer-Survey-Infographic-Start.pptx
+++ b/activities/Activity-01-Decode-a-Customer-Survey-Infographic/A01-Decode-a-Customer-Survey-Infographic-Start.pptx
@@ -7,6 +7,7 @@
   <p:sldIdLst>
     <p:sldId id="256" r:id="rId7"/>
     <p:sldId id="257" r:id="rId8"/>
+    <p:sldId id="258" r:id="rId9"/>
   </p:sldIdLst>
   <p:sldSz cx="12191695" cy="6858000" type="screen4x3"/>
   <p:notesSz cx="6858000" cy="9144000"/>
@@ -3289,7 +3290,7 @@
                 </a:solidFill>
                 <a:latin typeface="Arial"/>
               </a:rPr>
-              <a:t>Decode a Customer Survey Infographic</a:t>
+              <a:t>Use AI to Clean Data and Extract Insights</a:t>
             </a:r>
           </a:p>
         </p:txBody>
@@ -3439,7 +3440,7 @@
                 </a:solidFill>
                 <a:latin typeface="Arial"/>
               </a:rPr>
-              <a:t>PowerPoint + Excel</a:t>
+              <a:t>Approved AI assistant + Excel + PowerPoint</a:t>
             </a:r>
           </a:p>
         </p:txBody>
@@ -3522,11 +3523,11 @@
             <a:avLst/>
           </a:prstGeom>
           <a:solidFill>
-            <a:srgbClr val="10B981"/>
+            <a:srgbClr val="7C3AED"/>
           </a:solidFill>
           <a:ln>
             <a:solidFill>
-              <a:srgbClr val="10B981"/>
+              <a:srgbClr val="7C3AED"/>
             </a:solidFill>
           </a:ln>
         </p:spPr>
@@ -3578,11 +3579,11 @@
             <a:r>
               <a:rPr sz="1100" b="1">
                 <a:solidFill>
-                  <a:srgbClr val="10B981"/>
+                  <a:srgbClr val="7C3AED"/>
                 </a:solidFill>
                 <a:latin typeface="Arial"/>
               </a:rPr>
-              <a:t>ACTIVITY 01 · EDITABLE CANVAS</a:t>
+              <a:t>ACTIVITY 01 · FULL COPY-READY TEXT IN PROMPTS.MD AND AI PROMPT LAB</a:t>
             </a:r>
           </a:p>
         </p:txBody>
@@ -3617,7 +3618,7 @@
                 </a:solidFill>
                 <a:latin typeface="Arial"/>
               </a:rPr>
-              <a:t>Build Here</a:t>
+              <a:t>AI Prompt Starters</a:t>
             </a:r>
           </a:p>
         </p:txBody>
@@ -3697,7 +3698,1225 @@
                 </a:solidFill>
                 <a:latin typeface="Arial"/>
               </a:rPr>
-              <a:t>TGS-2024048310 · ACTIVITY PRACTICE · Tertiary Infotech Academy Pte Ltd</a:t>
+              <a:t>TGS-2026064178 · ACTIVITY PRACTICE · Tertiary Infotech Academy Pte Ltd</a:t>
+            </a:r>
+          </a:p>
+        </p:txBody>
+      </p:sp>
+      <p:sp>
+        <p:nvSpPr>
+          <p:cNvPr id="8" name="Rounded Rectangle 7"/>
+          <p:cNvSpPr/>
+          <p:nvPr/>
+        </p:nvSpPr>
+        <p:spPr>
+          <a:xfrm>
+            <a:off x="731520" y="1755648"/>
+            <a:ext cx="5166360" cy="1847088"/>
+          </a:xfrm>
+          <a:prstGeom prst="roundRect">
+            <a:avLst/>
+          </a:prstGeom>
+          <a:solidFill>
+            <a:srgbClr val="F5F8FC"/>
+          </a:solidFill>
+          <a:ln>
+            <a:solidFill>
+              <a:srgbClr val="E2E8F0"/>
+            </a:solidFill>
+          </a:ln>
+        </p:spPr>
+        <p:style>
+          <a:lnRef idx="1">
+            <a:schemeClr val="accent1"/>
+          </a:lnRef>
+          <a:fillRef idx="3">
+            <a:schemeClr val="accent1"/>
+          </a:fillRef>
+          <a:effectRef idx="2">
+            <a:schemeClr val="accent1"/>
+          </a:effectRef>
+          <a:fontRef idx="minor">
+            <a:schemeClr val="lt1"/>
+          </a:fontRef>
+        </p:style>
+        <p:txBody>
+          <a:bodyPr rtlCol="0" anchor="ctr"/>
+          <a:lstStyle/>
+          <a:p>
+            <a:pPr algn="ctr"/>
+          </a:p>
+        </p:txBody>
+      </p:sp>
+      <p:sp>
+        <p:nvSpPr>
+          <p:cNvPr id="9" name="Rectangle 8"/>
+          <p:cNvSpPr/>
+          <p:nvPr/>
+        </p:nvSpPr>
+        <p:spPr>
+          <a:xfrm>
+            <a:off x="731520" y="1755648"/>
+            <a:ext cx="73152" cy="1847088"/>
+          </a:xfrm>
+          <a:prstGeom prst="rect">
+            <a:avLst/>
+          </a:prstGeom>
+          <a:solidFill>
+            <a:srgbClr val="1F6FEB"/>
+          </a:solidFill>
+          <a:ln>
+            <a:solidFill>
+              <a:srgbClr val="1F6FEB"/>
+            </a:solidFill>
+          </a:ln>
+        </p:spPr>
+        <p:style>
+          <a:lnRef idx="1">
+            <a:schemeClr val="accent1"/>
+          </a:lnRef>
+          <a:fillRef idx="3">
+            <a:schemeClr val="accent1"/>
+          </a:fillRef>
+          <a:effectRef idx="2">
+            <a:schemeClr val="accent1"/>
+          </a:effectRef>
+          <a:fontRef idx="minor">
+            <a:schemeClr val="lt1"/>
+          </a:fontRef>
+        </p:style>
+        <p:txBody>
+          <a:bodyPr rtlCol="0" anchor="ctr"/>
+          <a:lstStyle/>
+          <a:p>
+            <a:pPr algn="ctr"/>
+          </a:p>
+        </p:txBody>
+      </p:sp>
+      <p:sp>
+        <p:nvSpPr>
+          <p:cNvPr id="10" name="Rounded Rectangle 9"/>
+          <p:cNvSpPr/>
+          <p:nvPr/>
+        </p:nvSpPr>
+        <p:spPr>
+          <a:xfrm>
+            <a:off x="932688" y="1975104"/>
+            <a:ext cx="438912" cy="438912"/>
+          </a:xfrm>
+          <a:prstGeom prst="roundRect">
+            <a:avLst/>
+          </a:prstGeom>
+          <a:solidFill>
+            <a:srgbClr val="1F6FEB"/>
+          </a:solidFill>
+          <a:ln>
+            <a:solidFill>
+              <a:srgbClr val="1F6FEB"/>
+            </a:solidFill>
+          </a:ln>
+        </p:spPr>
+        <p:style>
+          <a:lnRef idx="1">
+            <a:schemeClr val="accent1"/>
+          </a:lnRef>
+          <a:fillRef idx="3">
+            <a:schemeClr val="accent1"/>
+          </a:fillRef>
+          <a:effectRef idx="2">
+            <a:schemeClr val="accent1"/>
+          </a:effectRef>
+          <a:fontRef idx="minor">
+            <a:schemeClr val="lt1"/>
+          </a:fontRef>
+        </p:style>
+        <p:txBody>
+          <a:bodyPr rtlCol="0" anchor="ctr"/>
+          <a:lstStyle/>
+          <a:p>
+            <a:pPr algn="ctr"/>
+          </a:p>
+        </p:txBody>
+      </p:sp>
+      <p:sp>
+        <p:nvSpPr>
+          <p:cNvPr id="11" name="TextBox 10"/>
+          <p:cNvSpPr txBox="1"/>
+          <p:nvPr/>
+        </p:nvSpPr>
+        <p:spPr>
+          <a:xfrm>
+            <a:off x="932688" y="1984248"/>
+            <a:ext cx="438912" cy="420624"/>
+          </a:xfrm>
+          <a:prstGeom prst="rect">
+            <a:avLst/>
+          </a:prstGeom>
+          <a:noFill/>
+        </p:spPr>
+        <p:txBody>
+          <a:bodyPr wrap="square" anchor="ctr">
+            <a:spAutoFit/>
+          </a:bodyPr>
+          <a:lstStyle/>
+          <a:p>
+            <a:pPr algn="ctr"/>
+            <a:r>
+              <a:rPr sz="1400" b="1">
+                <a:solidFill>
+                  <a:srgbClr val="FFFFFF"/>
+                </a:solidFill>
+                <a:latin typeface="Arial"/>
+              </a:rPr>
+              <a:t>1</a:t>
+            </a:r>
+          </a:p>
+        </p:txBody>
+      </p:sp>
+      <p:sp>
+        <p:nvSpPr>
+          <p:cNvPr id="12" name="TextBox 11"/>
+          <p:cNvSpPr txBox="1"/>
+          <p:nvPr/>
+        </p:nvSpPr>
+        <p:spPr>
+          <a:xfrm>
+            <a:off x="1536192" y="1938528"/>
+            <a:ext cx="4178808" cy="329184"/>
+          </a:xfrm>
+          <a:prstGeom prst="rect">
+            <a:avLst/>
+          </a:prstGeom>
+          <a:noFill/>
+        </p:spPr>
+        <p:txBody>
+          <a:bodyPr wrap="square" anchor="t">
+            <a:spAutoFit/>
+          </a:bodyPr>
+          <a:lstStyle/>
+          <a:p>
+            <a:pPr algn="l"/>
+            <a:r>
+              <a:rPr sz="1400" b="1">
+                <a:solidFill>
+                  <a:srgbClr val="1F6FEB"/>
+                </a:solidFill>
+                <a:latin typeface="Arial"/>
+              </a:rPr>
+              <a:t>Data analyst</a:t>
+            </a:r>
+          </a:p>
+        </p:txBody>
+      </p:sp>
+      <p:sp>
+        <p:nvSpPr>
+          <p:cNvPr id="13" name="TextBox 12"/>
+          <p:cNvSpPr txBox="1"/>
+          <p:nvPr/>
+        </p:nvSpPr>
+        <p:spPr>
+          <a:xfrm>
+            <a:off x="1536192" y="2322576"/>
+            <a:ext cx="4178808" cy="1133856"/>
+          </a:xfrm>
+          <a:prstGeom prst="rect">
+            <a:avLst/>
+          </a:prstGeom>
+          <a:noFill/>
+        </p:spPr>
+        <p:txBody>
+          <a:bodyPr wrap="square" anchor="t">
+            <a:spAutoFit/>
+          </a:bodyPr>
+          <a:lstStyle/>
+          <a:p>
+            <a:pPr algn="l"/>
+            <a:r>
+              <a:rPr sz="1150" b="0">
+                <a:solidFill>
+                  <a:srgbClr val="161B26"/>
+                </a:solidFill>
+                <a:latin typeface="Arial"/>
+              </a:rPr>
+              <a:t>Using only the attached approved sources, create a source register, identify duplicates or conflicting definitions, clean the table, show formulas or transformations, and return five candidate insights with citations, caveats and a con…</a:t>
+            </a:r>
+          </a:p>
+        </p:txBody>
+      </p:sp>
+      <p:sp>
+        <p:nvSpPr>
+          <p:cNvPr id="14" name="Rounded Rectangle 13"/>
+          <p:cNvSpPr/>
+          <p:nvPr/>
+        </p:nvSpPr>
+        <p:spPr>
+          <a:xfrm>
+            <a:off x="6144768" y="1755648"/>
+            <a:ext cx="5166360" cy="1847088"/>
+          </a:xfrm>
+          <a:prstGeom prst="roundRect">
+            <a:avLst/>
+          </a:prstGeom>
+          <a:solidFill>
+            <a:srgbClr val="F5F8FC"/>
+          </a:solidFill>
+          <a:ln>
+            <a:solidFill>
+              <a:srgbClr val="E2E8F0"/>
+            </a:solidFill>
+          </a:ln>
+        </p:spPr>
+        <p:style>
+          <a:lnRef idx="1">
+            <a:schemeClr val="accent1"/>
+          </a:lnRef>
+          <a:fillRef idx="3">
+            <a:schemeClr val="accent1"/>
+          </a:fillRef>
+          <a:effectRef idx="2">
+            <a:schemeClr val="accent1"/>
+          </a:effectRef>
+          <a:fontRef idx="minor">
+            <a:schemeClr val="lt1"/>
+          </a:fontRef>
+        </p:style>
+        <p:txBody>
+          <a:bodyPr rtlCol="0" anchor="ctr"/>
+          <a:lstStyle/>
+          <a:p>
+            <a:pPr algn="ctr"/>
+          </a:p>
+        </p:txBody>
+      </p:sp>
+      <p:sp>
+        <p:nvSpPr>
+          <p:cNvPr id="15" name="Rectangle 14"/>
+          <p:cNvSpPr/>
+          <p:nvPr/>
+        </p:nvSpPr>
+        <p:spPr>
+          <a:xfrm>
+            <a:off x="6144768" y="1755648"/>
+            <a:ext cx="73152" cy="1847088"/>
+          </a:xfrm>
+          <a:prstGeom prst="rect">
+            <a:avLst/>
+          </a:prstGeom>
+          <a:solidFill>
+            <a:srgbClr val="10B981"/>
+          </a:solidFill>
+          <a:ln>
+            <a:solidFill>
+              <a:srgbClr val="10B981"/>
+            </a:solidFill>
+          </a:ln>
+        </p:spPr>
+        <p:style>
+          <a:lnRef idx="1">
+            <a:schemeClr val="accent1"/>
+          </a:lnRef>
+          <a:fillRef idx="3">
+            <a:schemeClr val="accent1"/>
+          </a:fillRef>
+          <a:effectRef idx="2">
+            <a:schemeClr val="accent1"/>
+          </a:effectRef>
+          <a:fontRef idx="minor">
+            <a:schemeClr val="lt1"/>
+          </a:fontRef>
+        </p:style>
+        <p:txBody>
+          <a:bodyPr rtlCol="0" anchor="ctr"/>
+          <a:lstStyle/>
+          <a:p>
+            <a:pPr algn="ctr"/>
+          </a:p>
+        </p:txBody>
+      </p:sp>
+      <p:sp>
+        <p:nvSpPr>
+          <p:cNvPr id="16" name="Rounded Rectangle 15"/>
+          <p:cNvSpPr/>
+          <p:nvPr/>
+        </p:nvSpPr>
+        <p:spPr>
+          <a:xfrm>
+            <a:off x="6345936" y="1975104"/>
+            <a:ext cx="438912" cy="438912"/>
+          </a:xfrm>
+          <a:prstGeom prst="roundRect">
+            <a:avLst/>
+          </a:prstGeom>
+          <a:solidFill>
+            <a:srgbClr val="10B981"/>
+          </a:solidFill>
+          <a:ln>
+            <a:solidFill>
+              <a:srgbClr val="10B981"/>
+            </a:solidFill>
+          </a:ln>
+        </p:spPr>
+        <p:style>
+          <a:lnRef idx="1">
+            <a:schemeClr val="accent1"/>
+          </a:lnRef>
+          <a:fillRef idx="3">
+            <a:schemeClr val="accent1"/>
+          </a:fillRef>
+          <a:effectRef idx="2">
+            <a:schemeClr val="accent1"/>
+          </a:effectRef>
+          <a:fontRef idx="minor">
+            <a:schemeClr val="lt1"/>
+          </a:fontRef>
+        </p:style>
+        <p:txBody>
+          <a:bodyPr rtlCol="0" anchor="ctr"/>
+          <a:lstStyle/>
+          <a:p>
+            <a:pPr algn="ctr"/>
+          </a:p>
+        </p:txBody>
+      </p:sp>
+      <p:sp>
+        <p:nvSpPr>
+          <p:cNvPr id="17" name="TextBox 16"/>
+          <p:cNvSpPr txBox="1"/>
+          <p:nvPr/>
+        </p:nvSpPr>
+        <p:spPr>
+          <a:xfrm>
+            <a:off x="6345936" y="1984248"/>
+            <a:ext cx="438912" cy="420624"/>
+          </a:xfrm>
+          <a:prstGeom prst="rect">
+            <a:avLst/>
+          </a:prstGeom>
+          <a:noFill/>
+        </p:spPr>
+        <p:txBody>
+          <a:bodyPr wrap="square" anchor="ctr">
+            <a:spAutoFit/>
+          </a:bodyPr>
+          <a:lstStyle/>
+          <a:p>
+            <a:pPr algn="ctr"/>
+            <a:r>
+              <a:rPr sz="1400" b="1">
+                <a:solidFill>
+                  <a:srgbClr val="FFFFFF"/>
+                </a:solidFill>
+                <a:latin typeface="Arial"/>
+              </a:rPr>
+              <a:t>2</a:t>
+            </a:r>
+          </a:p>
+        </p:txBody>
+      </p:sp>
+      <p:sp>
+        <p:nvSpPr>
+          <p:cNvPr id="18" name="TextBox 17"/>
+          <p:cNvSpPr txBox="1"/>
+          <p:nvPr/>
+        </p:nvSpPr>
+        <p:spPr>
+          <a:xfrm>
+            <a:off x="6949440" y="1938528"/>
+            <a:ext cx="4178808" cy="329184"/>
+          </a:xfrm>
+          <a:prstGeom prst="rect">
+            <a:avLst/>
+          </a:prstGeom>
+          <a:noFill/>
+        </p:spPr>
+        <p:txBody>
+          <a:bodyPr wrap="square" anchor="t">
+            <a:spAutoFit/>
+          </a:bodyPr>
+          <a:lstStyle/>
+          <a:p>
+            <a:pPr algn="l"/>
+            <a:r>
+              <a:rPr sz="1400" b="1">
+                <a:solidFill>
+                  <a:srgbClr val="10B981"/>
+                </a:solidFill>
+                <a:latin typeface="Arial"/>
+              </a:rPr>
+              <a:t>Infographic</a:t>
+            </a:r>
+          </a:p>
+        </p:txBody>
+      </p:sp>
+      <p:sp>
+        <p:nvSpPr>
+          <p:cNvPr id="19" name="TextBox 18"/>
+          <p:cNvSpPr txBox="1"/>
+          <p:nvPr/>
+        </p:nvSpPr>
+        <p:spPr>
+          <a:xfrm>
+            <a:off x="6949440" y="2322576"/>
+            <a:ext cx="4178808" cy="1133856"/>
+          </a:xfrm>
+          <a:prstGeom prst="rect">
+            <a:avLst/>
+          </a:prstGeom>
+          <a:noFill/>
+        </p:spPr>
+        <p:txBody>
+          <a:bodyPr wrap="square" anchor="t">
+            <a:spAutoFit/>
+          </a:bodyPr>
+          <a:lstStyle/>
+          <a:p>
+            <a:pPr algn="l"/>
+            <a:r>
+              <a:rPr sz="1150" b="0">
+                <a:solidFill>
+                  <a:srgbClr val="161B26"/>
+                </a:solidFill>
+                <a:latin typeface="Arial"/>
+              </a:rPr>
+              <a:t>Create a one-page executive infographic for Singapore retail managers. Lead with one decision insight, show three supporting metrics, include a five-stage flow and a source footer. Use a clean professional style, strong hierarchy and n…</a:t>
+            </a:r>
+          </a:p>
+        </p:txBody>
+      </p:sp>
+      <p:sp>
+        <p:nvSpPr>
+          <p:cNvPr id="20" name="Rounded Rectangle 19"/>
+          <p:cNvSpPr/>
+          <p:nvPr/>
+        </p:nvSpPr>
+        <p:spPr>
+          <a:xfrm>
+            <a:off x="731520" y="3877056"/>
+            <a:ext cx="5166360" cy="1847088"/>
+          </a:xfrm>
+          <a:prstGeom prst="roundRect">
+            <a:avLst/>
+          </a:prstGeom>
+          <a:solidFill>
+            <a:srgbClr val="F5F8FC"/>
+          </a:solidFill>
+          <a:ln>
+            <a:solidFill>
+              <a:srgbClr val="E2E8F0"/>
+            </a:solidFill>
+          </a:ln>
+        </p:spPr>
+        <p:style>
+          <a:lnRef idx="1">
+            <a:schemeClr val="accent1"/>
+          </a:lnRef>
+          <a:fillRef idx="3">
+            <a:schemeClr val="accent1"/>
+          </a:fillRef>
+          <a:effectRef idx="2">
+            <a:schemeClr val="accent1"/>
+          </a:effectRef>
+          <a:fontRef idx="minor">
+            <a:schemeClr val="lt1"/>
+          </a:fontRef>
+        </p:style>
+        <p:txBody>
+          <a:bodyPr rtlCol="0" anchor="ctr"/>
+          <a:lstStyle/>
+          <a:p>
+            <a:pPr algn="ctr"/>
+          </a:p>
+        </p:txBody>
+      </p:sp>
+      <p:sp>
+        <p:nvSpPr>
+          <p:cNvPr id="21" name="Rectangle 20"/>
+          <p:cNvSpPr/>
+          <p:nvPr/>
+        </p:nvSpPr>
+        <p:spPr>
+          <a:xfrm>
+            <a:off x="731520" y="3877056"/>
+            <a:ext cx="73152" cy="1847088"/>
+          </a:xfrm>
+          <a:prstGeom prst="rect">
+            <a:avLst/>
+          </a:prstGeom>
+          <a:solidFill>
+            <a:srgbClr val="7C3AED"/>
+          </a:solidFill>
+          <a:ln>
+            <a:solidFill>
+              <a:srgbClr val="7C3AED"/>
+            </a:solidFill>
+          </a:ln>
+        </p:spPr>
+        <p:style>
+          <a:lnRef idx="1">
+            <a:schemeClr val="accent1"/>
+          </a:lnRef>
+          <a:fillRef idx="3">
+            <a:schemeClr val="accent1"/>
+          </a:fillRef>
+          <a:effectRef idx="2">
+            <a:schemeClr val="accent1"/>
+          </a:effectRef>
+          <a:fontRef idx="minor">
+            <a:schemeClr val="lt1"/>
+          </a:fontRef>
+        </p:style>
+        <p:txBody>
+          <a:bodyPr rtlCol="0" anchor="ctr"/>
+          <a:lstStyle/>
+          <a:p>
+            <a:pPr algn="ctr"/>
+          </a:p>
+        </p:txBody>
+      </p:sp>
+      <p:sp>
+        <p:nvSpPr>
+          <p:cNvPr id="22" name="Rounded Rectangle 21"/>
+          <p:cNvSpPr/>
+          <p:nvPr/>
+        </p:nvSpPr>
+        <p:spPr>
+          <a:xfrm>
+            <a:off x="932688" y="4096512"/>
+            <a:ext cx="438912" cy="438912"/>
+          </a:xfrm>
+          <a:prstGeom prst="roundRect">
+            <a:avLst/>
+          </a:prstGeom>
+          <a:solidFill>
+            <a:srgbClr val="7C3AED"/>
+          </a:solidFill>
+          <a:ln>
+            <a:solidFill>
+              <a:srgbClr val="7C3AED"/>
+            </a:solidFill>
+          </a:ln>
+        </p:spPr>
+        <p:style>
+          <a:lnRef idx="1">
+            <a:schemeClr val="accent1"/>
+          </a:lnRef>
+          <a:fillRef idx="3">
+            <a:schemeClr val="accent1"/>
+          </a:fillRef>
+          <a:effectRef idx="2">
+            <a:schemeClr val="accent1"/>
+          </a:effectRef>
+          <a:fontRef idx="minor">
+            <a:schemeClr val="lt1"/>
+          </a:fontRef>
+        </p:style>
+        <p:txBody>
+          <a:bodyPr rtlCol="0" anchor="ctr"/>
+          <a:lstStyle/>
+          <a:p>
+            <a:pPr algn="ctr"/>
+          </a:p>
+        </p:txBody>
+      </p:sp>
+      <p:sp>
+        <p:nvSpPr>
+          <p:cNvPr id="23" name="TextBox 22"/>
+          <p:cNvSpPr txBox="1"/>
+          <p:nvPr/>
+        </p:nvSpPr>
+        <p:spPr>
+          <a:xfrm>
+            <a:off x="932688" y="4105656"/>
+            <a:ext cx="438912" cy="420624"/>
+          </a:xfrm>
+          <a:prstGeom prst="rect">
+            <a:avLst/>
+          </a:prstGeom>
+          <a:noFill/>
+        </p:spPr>
+        <p:txBody>
+          <a:bodyPr wrap="square" anchor="ctr">
+            <a:spAutoFit/>
+          </a:bodyPr>
+          <a:lstStyle/>
+          <a:p>
+            <a:pPr algn="ctr"/>
+            <a:r>
+              <a:rPr sz="1400" b="1">
+                <a:solidFill>
+                  <a:srgbClr val="FFFFFF"/>
+                </a:solidFill>
+                <a:latin typeface="Arial"/>
+              </a:rPr>
+              <a:t>3</a:t>
+            </a:r>
+          </a:p>
+        </p:txBody>
+      </p:sp>
+      <p:sp>
+        <p:nvSpPr>
+          <p:cNvPr id="24" name="TextBox 23"/>
+          <p:cNvSpPr txBox="1"/>
+          <p:nvPr/>
+        </p:nvSpPr>
+        <p:spPr>
+          <a:xfrm>
+            <a:off x="1536192" y="4059936"/>
+            <a:ext cx="4178808" cy="329184"/>
+          </a:xfrm>
+          <a:prstGeom prst="rect">
+            <a:avLst/>
+          </a:prstGeom>
+          <a:noFill/>
+        </p:spPr>
+        <p:txBody>
+          <a:bodyPr wrap="square" anchor="t">
+            <a:spAutoFit/>
+          </a:bodyPr>
+          <a:lstStyle/>
+          <a:p>
+            <a:pPr algn="l"/>
+            <a:r>
+              <a:rPr sz="1400" b="1">
+                <a:solidFill>
+                  <a:srgbClr val="7C3AED"/>
+                </a:solidFill>
+                <a:latin typeface="Arial"/>
+              </a:rPr>
+              <a:t>Text to image</a:t>
+            </a:r>
+          </a:p>
+        </p:txBody>
+      </p:sp>
+      <p:sp>
+        <p:nvSpPr>
+          <p:cNvPr id="25" name="TextBox 24"/>
+          <p:cNvSpPr txBox="1"/>
+          <p:nvPr/>
+        </p:nvSpPr>
+        <p:spPr>
+          <a:xfrm>
+            <a:off x="1536192" y="4443984"/>
+            <a:ext cx="4178808" cy="1133856"/>
+          </a:xfrm>
+          <a:prstGeom prst="rect">
+            <a:avLst/>
+          </a:prstGeom>
+          <a:noFill/>
+        </p:spPr>
+        <p:txBody>
+          <a:bodyPr wrap="square" anchor="t">
+            <a:spAutoFit/>
+          </a:bodyPr>
+          <a:lstStyle/>
+          <a:p>
+            <a:pPr algn="l"/>
+            <a:r>
+              <a:rPr sz="1150" b="0">
+                <a:solidFill>
+                  <a:srgbClr val="161B26"/>
+                </a:solidFill>
+                <a:latin typeface="Arial"/>
+              </a:rPr>
+              <a:t>Create a clean vector-like sustainability delivery illustration for a PowerPoint infographic: one electric van, one reusable parcel, a simple route and a feedback symbol. Transparent background, consistent blue/teal/violet/amber palett…</a:t>
+            </a:r>
+          </a:p>
+        </p:txBody>
+      </p:sp>
+      <p:sp>
+        <p:nvSpPr>
+          <p:cNvPr id="26" name="Rounded Rectangle 25"/>
+          <p:cNvSpPr/>
+          <p:nvPr/>
+        </p:nvSpPr>
+        <p:spPr>
+          <a:xfrm>
+            <a:off x="6144768" y="3877056"/>
+            <a:ext cx="5166360" cy="1847088"/>
+          </a:xfrm>
+          <a:prstGeom prst="roundRect">
+            <a:avLst/>
+          </a:prstGeom>
+          <a:solidFill>
+            <a:srgbClr val="F5F8FC"/>
+          </a:solidFill>
+          <a:ln>
+            <a:solidFill>
+              <a:srgbClr val="E2E8F0"/>
+            </a:solidFill>
+          </a:ln>
+        </p:spPr>
+        <p:style>
+          <a:lnRef idx="1">
+            <a:schemeClr val="accent1"/>
+          </a:lnRef>
+          <a:fillRef idx="3">
+            <a:schemeClr val="accent1"/>
+          </a:fillRef>
+          <a:effectRef idx="2">
+            <a:schemeClr val="accent1"/>
+          </a:effectRef>
+          <a:fontRef idx="minor">
+            <a:schemeClr val="lt1"/>
+          </a:fontRef>
+        </p:style>
+        <p:txBody>
+          <a:bodyPr rtlCol="0" anchor="ctr"/>
+          <a:lstStyle/>
+          <a:p>
+            <a:pPr algn="ctr"/>
+          </a:p>
+        </p:txBody>
+      </p:sp>
+      <p:sp>
+        <p:nvSpPr>
+          <p:cNvPr id="27" name="Rectangle 26"/>
+          <p:cNvSpPr/>
+          <p:nvPr/>
+        </p:nvSpPr>
+        <p:spPr>
+          <a:xfrm>
+            <a:off x="6144768" y="3877056"/>
+            <a:ext cx="73152" cy="1847088"/>
+          </a:xfrm>
+          <a:prstGeom prst="rect">
+            <a:avLst/>
+          </a:prstGeom>
+          <a:solidFill>
+            <a:srgbClr val="F59E0B"/>
+          </a:solidFill>
+          <a:ln>
+            <a:solidFill>
+              <a:srgbClr val="F59E0B"/>
+            </a:solidFill>
+          </a:ln>
+        </p:spPr>
+        <p:style>
+          <a:lnRef idx="1">
+            <a:schemeClr val="accent1"/>
+          </a:lnRef>
+          <a:fillRef idx="3">
+            <a:schemeClr val="accent1"/>
+          </a:fillRef>
+          <a:effectRef idx="2">
+            <a:schemeClr val="accent1"/>
+          </a:effectRef>
+          <a:fontRef idx="minor">
+            <a:schemeClr val="lt1"/>
+          </a:fontRef>
+        </p:style>
+        <p:txBody>
+          <a:bodyPr rtlCol="0" anchor="ctr"/>
+          <a:lstStyle/>
+          <a:p>
+            <a:pPr algn="ctr"/>
+          </a:p>
+        </p:txBody>
+      </p:sp>
+      <p:sp>
+        <p:nvSpPr>
+          <p:cNvPr id="28" name="Rounded Rectangle 27"/>
+          <p:cNvSpPr/>
+          <p:nvPr/>
+        </p:nvSpPr>
+        <p:spPr>
+          <a:xfrm>
+            <a:off x="6345936" y="4096512"/>
+            <a:ext cx="438912" cy="438912"/>
+          </a:xfrm>
+          <a:prstGeom prst="roundRect">
+            <a:avLst/>
+          </a:prstGeom>
+          <a:solidFill>
+            <a:srgbClr val="F59E0B"/>
+          </a:solidFill>
+          <a:ln>
+            <a:solidFill>
+              <a:srgbClr val="F59E0B"/>
+            </a:solidFill>
+          </a:ln>
+        </p:spPr>
+        <p:style>
+          <a:lnRef idx="1">
+            <a:schemeClr val="accent1"/>
+          </a:lnRef>
+          <a:fillRef idx="3">
+            <a:schemeClr val="accent1"/>
+          </a:fillRef>
+          <a:effectRef idx="2">
+            <a:schemeClr val="accent1"/>
+          </a:effectRef>
+          <a:fontRef idx="minor">
+            <a:schemeClr val="lt1"/>
+          </a:fontRef>
+        </p:style>
+        <p:txBody>
+          <a:bodyPr rtlCol="0" anchor="ctr"/>
+          <a:lstStyle/>
+          <a:p>
+            <a:pPr algn="ctr"/>
+          </a:p>
+        </p:txBody>
+      </p:sp>
+      <p:sp>
+        <p:nvSpPr>
+          <p:cNvPr id="29" name="TextBox 28"/>
+          <p:cNvSpPr txBox="1"/>
+          <p:nvPr/>
+        </p:nvSpPr>
+        <p:spPr>
+          <a:xfrm>
+            <a:off x="6345936" y="4105656"/>
+            <a:ext cx="438912" cy="420624"/>
+          </a:xfrm>
+          <a:prstGeom prst="rect">
+            <a:avLst/>
+          </a:prstGeom>
+          <a:noFill/>
+        </p:spPr>
+        <p:txBody>
+          <a:bodyPr wrap="square" anchor="ctr">
+            <a:spAutoFit/>
+          </a:bodyPr>
+          <a:lstStyle/>
+          <a:p>
+            <a:pPr algn="ctr"/>
+            <a:r>
+              <a:rPr sz="1400" b="1">
+                <a:solidFill>
+                  <a:srgbClr val="FFFFFF"/>
+                </a:solidFill>
+                <a:latin typeface="Arial"/>
+              </a:rPr>
+              <a:t>4</a:t>
+            </a:r>
+          </a:p>
+        </p:txBody>
+      </p:sp>
+      <p:sp>
+        <p:nvSpPr>
+          <p:cNvPr id="30" name="TextBox 29"/>
+          <p:cNvSpPr txBox="1"/>
+          <p:nvPr/>
+        </p:nvSpPr>
+        <p:spPr>
+          <a:xfrm>
+            <a:off x="6949440" y="4059936"/>
+            <a:ext cx="4178808" cy="329184"/>
+          </a:xfrm>
+          <a:prstGeom prst="rect">
+            <a:avLst/>
+          </a:prstGeom>
+          <a:noFill/>
+        </p:spPr>
+        <p:txBody>
+          <a:bodyPr wrap="square" anchor="t">
+            <a:spAutoFit/>
+          </a:bodyPr>
+          <a:lstStyle/>
+          <a:p>
+            <a:pPr algn="l"/>
+            <a:r>
+              <a:rPr sz="1400" b="1">
+                <a:solidFill>
+                  <a:srgbClr val="F59E0B"/>
+                </a:solidFill>
+                <a:latin typeface="Arial"/>
+              </a:rPr>
+              <a:t>Gemini Notebook deck</a:t>
+            </a:r>
+          </a:p>
+        </p:txBody>
+      </p:sp>
+      <p:sp>
+        <p:nvSpPr>
+          <p:cNvPr id="31" name="TextBox 30"/>
+          <p:cNvSpPr txBox="1"/>
+          <p:nvPr/>
+        </p:nvSpPr>
+        <p:spPr>
+          <a:xfrm>
+            <a:off x="6949440" y="4443984"/>
+            <a:ext cx="4178808" cy="1133856"/>
+          </a:xfrm>
+          <a:prstGeom prst="rect">
+            <a:avLst/>
+          </a:prstGeom>
+          <a:noFill/>
+        </p:spPr>
+        <p:txBody>
+          <a:bodyPr wrap="square" anchor="t">
+            <a:spAutoFit/>
+          </a:bodyPr>
+          <a:lstStyle/>
+          <a:p>
+            <a:pPr algn="l"/>
+            <a:r>
+              <a:rPr sz="1150" b="0">
+                <a:solidFill>
+                  <a:srgbClr val="161B26"/>
+                </a:solidFill>
+                <a:latin typeface="Arial"/>
+              </a:rPr>
+              <a:t>Create Presenter Slides for business stakeholders. Focus on the verified decision insight, use a concise professional style, include source-grounded comparisons and a final recommendation. Avoid claims not supported by selected sources…</a:t>
+            </a:r>
+          </a:p>
+        </p:txBody>
+      </p:sp>
+    </p:spTree>
+  </p:cSld>
+  <p:clrMapOvr>
+    <a:masterClrMapping/>
+  </p:clrMapOvr>
+</p:sld>
+</file>
+
+<file path=ppt/slides/slide3.xml><?xml version="1.0" encoding="utf-8"?>
+<p:sld xmlns:a="http://schemas.openxmlformats.org/drawingml/2006/main" xmlns:p="http://schemas.openxmlformats.org/presentationml/2006/main" xmlns:r="http://schemas.openxmlformats.org/officeDocument/2006/relationships">
+  <p:cSld>
+    <p:spTree>
+      <p:nvGrpSpPr>
+        <p:cNvPr id="1" name=""/>
+        <p:cNvGrpSpPr/>
+        <p:nvPr/>
+      </p:nvGrpSpPr>
+      <p:grpSpPr/>
+      <p:sp>
+        <p:nvSpPr>
+          <p:cNvPr id="2" name="Rectangle 1"/>
+          <p:cNvSpPr/>
+          <p:nvPr/>
+        </p:nvSpPr>
+        <p:spPr>
+          <a:xfrm>
+            <a:off x="0" y="0"/>
+            <a:ext cx="12191695" cy="6858000"/>
+          </a:xfrm>
+          <a:prstGeom prst="rect">
+            <a:avLst/>
+          </a:prstGeom>
+          <a:solidFill>
+            <a:srgbClr val="FFFFFF"/>
+          </a:solidFill>
+          <a:ln>
+            <a:solidFill>
+              <a:srgbClr val="FFFFFF"/>
+            </a:solidFill>
+          </a:ln>
+        </p:spPr>
+        <p:style>
+          <a:lnRef idx="1">
+            <a:schemeClr val="accent1"/>
+          </a:lnRef>
+          <a:fillRef idx="3">
+            <a:schemeClr val="accent1"/>
+          </a:fillRef>
+          <a:effectRef idx="2">
+            <a:schemeClr val="accent1"/>
+          </a:effectRef>
+          <a:fontRef idx="minor">
+            <a:schemeClr val="lt1"/>
+          </a:fontRef>
+        </p:style>
+        <p:txBody>
+          <a:bodyPr rtlCol="0" anchor="ctr"/>
+          <a:lstStyle/>
+          <a:p>
+            <a:pPr algn="ctr"/>
+          </a:p>
+        </p:txBody>
+      </p:sp>
+      <p:sp>
+        <p:nvSpPr>
+          <p:cNvPr id="3" name="Rectangle 2"/>
+          <p:cNvSpPr/>
+          <p:nvPr/>
+        </p:nvSpPr>
+        <p:spPr>
+          <a:xfrm>
+            <a:off x="0" y="0"/>
+            <a:ext cx="164592" cy="6858000"/>
+          </a:xfrm>
+          <a:prstGeom prst="rect">
+            <a:avLst/>
+          </a:prstGeom>
+          <a:solidFill>
+            <a:srgbClr val="10B981"/>
+          </a:solidFill>
+          <a:ln>
+            <a:solidFill>
+              <a:srgbClr val="10B981"/>
+            </a:solidFill>
+          </a:ln>
+        </p:spPr>
+        <p:style>
+          <a:lnRef idx="1">
+            <a:schemeClr val="accent1"/>
+          </a:lnRef>
+          <a:fillRef idx="3">
+            <a:schemeClr val="accent1"/>
+          </a:fillRef>
+          <a:effectRef idx="2">
+            <a:schemeClr val="accent1"/>
+          </a:effectRef>
+          <a:fontRef idx="minor">
+            <a:schemeClr val="lt1"/>
+          </a:fontRef>
+        </p:style>
+        <p:txBody>
+          <a:bodyPr rtlCol="0" anchor="ctr"/>
+          <a:lstStyle/>
+          <a:p>
+            <a:pPr algn="ctr"/>
+          </a:p>
+        </p:txBody>
+      </p:sp>
+      <p:sp>
+        <p:nvSpPr>
+          <p:cNvPr id="4" name="TextBox 3"/>
+          <p:cNvSpPr txBox="1"/>
+          <p:nvPr/>
+        </p:nvSpPr>
+        <p:spPr>
+          <a:xfrm>
+            <a:off x="658368" y="384048"/>
+            <a:ext cx="10789920" cy="320040"/>
+          </a:xfrm>
+          <a:prstGeom prst="rect">
+            <a:avLst/>
+          </a:prstGeom>
+          <a:noFill/>
+        </p:spPr>
+        <p:txBody>
+          <a:bodyPr wrap="square" anchor="t">
+            <a:spAutoFit/>
+          </a:bodyPr>
+          <a:lstStyle/>
+          <a:p>
+            <a:pPr algn="l"/>
+            <a:r>
+              <a:rPr sz="1100" b="1">
+                <a:solidFill>
+                  <a:srgbClr val="10B981"/>
+                </a:solidFill>
+                <a:latin typeface="Arial"/>
+              </a:rPr>
+              <a:t>ACTIVITY 01 · EDITABLE CANVAS</a:t>
+            </a:r>
+          </a:p>
+        </p:txBody>
+      </p:sp>
+      <p:sp>
+        <p:nvSpPr>
+          <p:cNvPr id="5" name="TextBox 4"/>
+          <p:cNvSpPr txBox="1"/>
+          <p:nvPr/>
+        </p:nvSpPr>
+        <p:spPr>
+          <a:xfrm>
+            <a:off x="658368" y="749808"/>
+            <a:ext cx="10789920" cy="658368"/>
+          </a:xfrm>
+          <a:prstGeom prst="rect">
+            <a:avLst/>
+          </a:prstGeom>
+          <a:noFill/>
+        </p:spPr>
+        <p:txBody>
+          <a:bodyPr wrap="square" anchor="t">
+            <a:spAutoFit/>
+          </a:bodyPr>
+          <a:lstStyle/>
+          <a:p>
+            <a:pPr algn="l"/>
+            <a:r>
+              <a:rPr sz="2700" b="1">
+                <a:solidFill>
+                  <a:srgbClr val="161B26"/>
+                </a:solidFill>
+                <a:latin typeface="Arial"/>
+              </a:rPr>
+              <a:t>Build Here</a:t>
+            </a:r>
+          </a:p>
+        </p:txBody>
+      </p:sp>
+      <p:sp>
+        <p:nvSpPr>
+          <p:cNvPr id="6" name="Rectangle 5"/>
+          <p:cNvSpPr/>
+          <p:nvPr/>
+        </p:nvSpPr>
+        <p:spPr>
+          <a:xfrm>
+            <a:off x="658368" y="1444752"/>
+            <a:ext cx="10881360" cy="18288"/>
+          </a:xfrm>
+          <a:prstGeom prst="rect">
+            <a:avLst/>
+          </a:prstGeom>
+          <a:solidFill>
+            <a:srgbClr val="E2E8F0"/>
+          </a:solidFill>
+          <a:ln>
+            <a:solidFill>
+              <a:srgbClr val="E2E8F0"/>
+            </a:solidFill>
+          </a:ln>
+        </p:spPr>
+        <p:style>
+          <a:lnRef idx="1">
+            <a:schemeClr val="accent1"/>
+          </a:lnRef>
+          <a:fillRef idx="3">
+            <a:schemeClr val="accent1"/>
+          </a:fillRef>
+          <a:effectRef idx="2">
+            <a:schemeClr val="accent1"/>
+          </a:effectRef>
+          <a:fontRef idx="minor">
+            <a:schemeClr val="lt1"/>
+          </a:fontRef>
+        </p:style>
+        <p:txBody>
+          <a:bodyPr rtlCol="0" anchor="ctr"/>
+          <a:lstStyle/>
+          <a:p>
+            <a:pPr algn="ctr"/>
+          </a:p>
+        </p:txBody>
+      </p:sp>
+      <p:sp>
+        <p:nvSpPr>
+          <p:cNvPr id="7" name="TextBox 6"/>
+          <p:cNvSpPr txBox="1"/>
+          <p:nvPr/>
+        </p:nvSpPr>
+        <p:spPr>
+          <a:xfrm>
+            <a:off x="658368" y="6473952"/>
+            <a:ext cx="9875520" cy="201168"/>
+          </a:xfrm>
+          <a:prstGeom prst="rect">
+            <a:avLst/>
+          </a:prstGeom>
+          <a:noFill/>
+        </p:spPr>
+        <p:txBody>
+          <a:bodyPr wrap="square" anchor="t">
+            <a:spAutoFit/>
+          </a:bodyPr>
+          <a:lstStyle/>
+          <a:p>
+            <a:pPr algn="l"/>
+            <a:r>
+              <a:rPr sz="800" b="0">
+                <a:solidFill>
+                  <a:srgbClr val="5B6372"/>
+                </a:solidFill>
+                <a:latin typeface="Arial"/>
+              </a:rPr>
+              <a:t>TGS-2026064178 · ACTIVITY PRACTICE · Tertiary Infotech Academy Pte Ltd</a:t>
             </a:r>
           </a:p>
         </p:txBody>

</xml_diff>